<commit_message>
AthDGC site update 2026-06-01 22:42 --- clean Quarto render, real Zenodo DOI 10.5281/zenodo.20439182, samples-only public release
</commit_message>
<xml_diff>
--- a/slides/cidl_2026.pptx
+++ b/slides/cidl_2026.pptx
@@ -4428,31 +4428,31 @@
               <a:rPr>
                 <a:latin typeface="Courier"/>
               </a:rPr>
-              <a:t>nsubj</a:t>
-            </a:r>
-            <a:r>
-              <a:rPr/>
-              <a:t>, </a:t>
+              <a:t>sub</a:t>
+            </a:r>
+            <a:r>
+              <a:rPr/>
+              <a:t>, including raised </a:t>
             </a:r>
             <a:r>
               <a:rPr>
                 <a:latin typeface="Courier"/>
               </a:rPr>
-              <a:t>nsubj:pass</a:t>
-            </a:r>
-            <a:r>
-              <a:rPr/>
-              <a:t>, </a:t>
+              <a:t>xobj</a:t>
+            </a:r>
+            <a:r>
+              <a:rPr/>
+              <a:t> / </a:t>
             </a:r>
             <a:r>
               <a:rPr>
                 <a:latin typeface="Courier"/>
               </a:rPr>
-              <a:t>csubj</a:t>
-            </a:r>
-            <a:r>
-              <a:rPr/>
-              <a:t>)</a:t>
+              <a:t>nonsub</a:t>
+            </a:r>
+            <a:r>
+              <a:rPr/>
+              <a:t> patterns)</a:t>
             </a:r>
           </a:p>
           <a:p>
@@ -4492,21 +4492,28 @@
               <a:rPr>
                 <a:latin typeface="Courier"/>
               </a:rPr>
-              <a:t>obl:arg</a:t>
-            </a:r>
-            <a:r>
-              <a:rPr/>
-              <a:t>, </a:t>
+              <a:t>obl</a:t>
+            </a:r>
+            <a:r>
+              <a:rPr/>
+              <a:t>)</a:t>
+            </a:r>
+          </a:p>
+          <a:p>
+            <a:pPr lvl="0"/>
+            <a:r>
+              <a:rPr/>
+              <a:t>vocative addressee (</a:t>
             </a:r>
             <a:r>
               <a:rPr>
                 <a:latin typeface="Courier"/>
               </a:rPr>
-              <a:t>obl:agent</a:t>
-            </a:r>
-            <a:r>
-              <a:rPr/>
-              <a:t>, …)</a:t>
+              <a:t>voc</a:t>
+            </a:r>
+            <a:r>
+              <a:rPr/>
+              <a:t>)</a:t>
             </a:r>
           </a:p>
           <a:p>

</xml_diff>